<commit_message>
Correct team details and complete application for published MVP
</commit_message>
<xml_diff>
--- a/presentation.pptx
+++ b/presentation.pptx
@@ -2,22 +2,22 @@
 <file path=ppt/presentation.xml><?xml version="1.0" encoding="utf-8"?>
 <p:presentation xmlns:p="http://schemas.openxmlformats.org/presentationml/2006/main">
   <p:sldMasterIdLst>
-    <p:sldMasterId xmlns:r="http://schemas.openxmlformats.org/officeDocument/2006/relationships" id="2147483648" r:id="Rc8b680ccaf8a4392"/>
+    <p:sldMasterId xmlns:r="http://schemas.openxmlformats.org/officeDocument/2006/relationships" id="2147483648" r:id="R31b3a723223f4955"/>
   </p:sldMasterIdLst>
   <p:notesMasterIdLst>
-    <p:notesMasterId xmlns:r="http://schemas.openxmlformats.org/officeDocument/2006/relationships" r:id="Rb05f780bdfa24081"/>
+    <p:notesMasterId xmlns:r="http://schemas.openxmlformats.org/officeDocument/2006/relationships" r:id="R9d33f670db3f4588"/>
   </p:notesMasterIdLst>
   <p:sldIdLst>
-    <p:sldId xmlns:r="http://schemas.openxmlformats.org/officeDocument/2006/relationships" id="256" r:id="R5060b10fb9c248d3"/>
-    <p:sldId xmlns:r="http://schemas.openxmlformats.org/officeDocument/2006/relationships" id="257" r:id="R53bd309b1e2f41aa"/>
-    <p:sldId xmlns:r="http://schemas.openxmlformats.org/officeDocument/2006/relationships" id="258" r:id="Rc8bf0322efd5472a"/>
-    <p:sldId xmlns:r="http://schemas.openxmlformats.org/officeDocument/2006/relationships" id="259" r:id="R4de17053be714a47"/>
-    <p:sldId xmlns:r="http://schemas.openxmlformats.org/officeDocument/2006/relationships" id="260" r:id="R318ad0ed581645ee"/>
-    <p:sldId xmlns:r="http://schemas.openxmlformats.org/officeDocument/2006/relationships" id="261" r:id="R2c400536e9db4904"/>
-    <p:sldId xmlns:r="http://schemas.openxmlformats.org/officeDocument/2006/relationships" id="262" r:id="R767915f59de84add"/>
-    <p:sldId xmlns:r="http://schemas.openxmlformats.org/officeDocument/2006/relationships" id="263" r:id="Ree7882e7ec2141f7"/>
-    <p:sldId xmlns:r="http://schemas.openxmlformats.org/officeDocument/2006/relationships" id="264" r:id="R5edd5b0bb64f426a"/>
-    <p:sldId xmlns:r="http://schemas.openxmlformats.org/officeDocument/2006/relationships" id="265" r:id="R6a4e21c7fd674e29"/>
+    <p:sldId xmlns:r="http://schemas.openxmlformats.org/officeDocument/2006/relationships" id="256" r:id="Rf33d149e9fba495a"/>
+    <p:sldId xmlns:r="http://schemas.openxmlformats.org/officeDocument/2006/relationships" id="257" r:id="R720c375f580f4c49"/>
+    <p:sldId xmlns:r="http://schemas.openxmlformats.org/officeDocument/2006/relationships" id="258" r:id="R44a55258f8554e80"/>
+    <p:sldId xmlns:r="http://schemas.openxmlformats.org/officeDocument/2006/relationships" id="259" r:id="R9739cb32a62e420d"/>
+    <p:sldId xmlns:r="http://schemas.openxmlformats.org/officeDocument/2006/relationships" id="260" r:id="Rd23da8283014487e"/>
+    <p:sldId xmlns:r="http://schemas.openxmlformats.org/officeDocument/2006/relationships" id="261" r:id="R0adb1d5ed3474ff0"/>
+    <p:sldId xmlns:r="http://schemas.openxmlformats.org/officeDocument/2006/relationships" id="262" r:id="R3d30407d6dde442d"/>
+    <p:sldId xmlns:r="http://schemas.openxmlformats.org/officeDocument/2006/relationships" id="263" r:id="R671192386db34aaa"/>
+    <p:sldId xmlns:r="http://schemas.openxmlformats.org/officeDocument/2006/relationships" id="264" r:id="R7e8d64dc9e0b41cc"/>
+    <p:sldId xmlns:r="http://schemas.openxmlformats.org/officeDocument/2006/relationships" id="265" r:id="R74d68801af3549fd"/>
   </p:sldIdLst>
   <p:sldSz cx="12192000" cy="6858000"/>
   <p:notesSz cx="6858000" cy="9144000"/>
@@ -521,7 +521,7 @@
           <a:lstStyle xmlns:a="http://schemas.openxmlformats.org/drawingml/2006/main"/>
           <a:p xmlns:a="http://schemas.openxmlformats.org/drawingml/2006/main">
             <a:r>
-              <a:t>Команда: Иван Сороковых и Михаил, магистранты ТИУ по информации пользователя. Фамилия Михаила не предоставлена и не выдумана. Роли являются планом распределения работы. Стадия: MVP. Исследования пользователей, пилота и подтверждённых продаж нет. Демо https://krackenhell.github.io/oplata-vovremya/ . Код https://github.com/Krackenhell/oplata-vovremya .</a:t>
+              <a:t>Команда: Иван Сороковых и Михаил Дементьев. Иван учится во ВШЭ на программе «Финансовые рынки и финансовые институты», по уточнению пользователя. Михаил работает инженером в НОВАТЭК. Роли являются планом распределения работы. Стадия: MVP. Исследования пользователей, пилота и подтверждённых продаж нет. Демо https://krackenhell.github.io/oplata-vovremya/ . Код https://github.com/Krackenhell/oplata-vovremya .</a:t>
             </a:r>
           </a:p>
         </p:txBody>
@@ -1128,7 +1128,7 @@
           <p:cNvPr id="3" name="Title">
             <a:extLst xmlns:a="http://schemas.openxmlformats.org/drawingml/2006/main">
               <a:ext uri="{FF2B5EF4-FFF2-40B4-BE49-F238E27FC236}">
-                <a16:creationId xmlns:a16="http://schemas.microsoft.com/office/drawing/2014/main" id="{C3EC9626-A6FE-4F83-99CD-52EBECEBFBFE}"/>
+                <a16:creationId xmlns:a16="http://schemas.microsoft.com/office/drawing/2014/main" id="{18DBE8CB-4A7C-40D9-BEDA-9AF820BD4AD7}"/>
               </a:ext>
             </a:extLst>
           </p:cNvPr>
@@ -1285,7 +1285,7 @@
           <p:cNvPr id="2" name="Subtitle">
             <a:extLst xmlns:a="http://schemas.openxmlformats.org/drawingml/2006/main">
               <a:ext uri="{FF2B5EF4-FFF2-40B4-BE49-F238E27FC236}">
-                <a16:creationId xmlns:a16="http://schemas.microsoft.com/office/drawing/2014/main" id="{26AEA647-7099-4B84-8007-231649202300}"/>
+                <a16:creationId xmlns:a16="http://schemas.microsoft.com/office/drawing/2014/main" id="{33E6B132-F383-4AD9-8A8C-6A70E274C5CA}"/>
               </a:ext>
             </a:extLst>
           </p:cNvPr>
@@ -1459,7 +1459,7 @@
           <p:cNvPr id="2" name="Section title">
             <a:extLst xmlns:a="http://schemas.openxmlformats.org/drawingml/2006/main">
               <a:ext uri="{FF2B5EF4-FFF2-40B4-BE49-F238E27FC236}">
-                <a16:creationId xmlns:a16="http://schemas.microsoft.com/office/drawing/2014/main" id="{20DA191F-9FEC-41DB-8B49-4B895B528CE8}"/>
+                <a16:creationId xmlns:a16="http://schemas.microsoft.com/office/drawing/2014/main" id="{33629072-C6F8-41F6-946B-712E860FA991}"/>
               </a:ext>
             </a:extLst>
           </p:cNvPr>
@@ -1633,7 +1633,7 @@
           <p:cNvPr id="3" name="Title">
             <a:extLst xmlns:a="http://schemas.openxmlformats.org/drawingml/2006/main">
               <a:ext uri="{FF2B5EF4-FFF2-40B4-BE49-F238E27FC236}">
-                <a16:creationId xmlns:a16="http://schemas.microsoft.com/office/drawing/2014/main" id="{4E9AF0D1-ECF6-4DCB-AAFB-E1F5F8F70C6F}"/>
+                <a16:creationId xmlns:a16="http://schemas.microsoft.com/office/drawing/2014/main" id="{29A3F4D0-995B-45BD-9C0E-217B6627694F}"/>
               </a:ext>
             </a:extLst>
           </p:cNvPr>
@@ -1790,7 +1790,7 @@
           <p:cNvPr id="2" name="Body">
             <a:extLst xmlns:a="http://schemas.openxmlformats.org/drawingml/2006/main">
               <a:ext uri="{FF2B5EF4-FFF2-40B4-BE49-F238E27FC236}">
-                <a16:creationId xmlns:a16="http://schemas.microsoft.com/office/drawing/2014/main" id="{CDFF4545-3F84-4BA0-995B-5454448B8B04}"/>
+                <a16:creationId xmlns:a16="http://schemas.microsoft.com/office/drawing/2014/main" id="{1745B6D4-1C10-4C67-9541-B8930C0982A2}"/>
               </a:ext>
             </a:extLst>
           </p:cNvPr>
@@ -1964,7 +1964,7 @@
           <p:cNvPr id="4" name="Title">
             <a:extLst xmlns:a="http://schemas.openxmlformats.org/drawingml/2006/main">
               <a:ext uri="{FF2B5EF4-FFF2-40B4-BE49-F238E27FC236}">
-                <a16:creationId xmlns:a16="http://schemas.microsoft.com/office/drawing/2014/main" id="{E78E7738-48CD-4E34-B6AF-17EC59483CA5}"/>
+                <a16:creationId xmlns:a16="http://schemas.microsoft.com/office/drawing/2014/main" id="{D69871D9-F8A6-43F6-BC1D-56289B5437CB}"/>
               </a:ext>
             </a:extLst>
           </p:cNvPr>
@@ -2121,7 +2121,7 @@
           <p:cNvPr id="2" name="Left column">
             <a:extLst xmlns:a="http://schemas.openxmlformats.org/drawingml/2006/main">
               <a:ext uri="{FF2B5EF4-FFF2-40B4-BE49-F238E27FC236}">
-                <a16:creationId xmlns:a16="http://schemas.microsoft.com/office/drawing/2014/main" id="{8110A89E-EBEC-44D5-99AE-0E9EAC7C40F3}"/>
+                <a16:creationId xmlns:a16="http://schemas.microsoft.com/office/drawing/2014/main" id="{810C0CBE-C600-4FEB-AE5A-50C477F270E2}"/>
               </a:ext>
             </a:extLst>
           </p:cNvPr>
@@ -2278,7 +2278,7 @@
           <p:cNvPr id="3" name="Right column">
             <a:extLst xmlns:a="http://schemas.openxmlformats.org/drawingml/2006/main">
               <a:ext uri="{FF2B5EF4-FFF2-40B4-BE49-F238E27FC236}">
-                <a16:creationId xmlns:a16="http://schemas.microsoft.com/office/drawing/2014/main" id="{7CAD76E0-4A5D-4DCB-B4F7-BDF3C58D843C}"/>
+                <a16:creationId xmlns:a16="http://schemas.microsoft.com/office/drawing/2014/main" id="{B88F6DEB-1647-4FC5-835D-D160ECC1BC40}"/>
               </a:ext>
             </a:extLst>
           </p:cNvPr>
@@ -2452,7 +2452,7 @@
           <p:cNvPr id="3" name="Title">
             <a:extLst xmlns:a="http://schemas.openxmlformats.org/drawingml/2006/main">
               <a:ext uri="{FF2B5EF4-FFF2-40B4-BE49-F238E27FC236}">
-                <a16:creationId xmlns:a16="http://schemas.microsoft.com/office/drawing/2014/main" id="{E42723BA-E1BB-4B7A-AE20-D52012DF6019}"/>
+                <a16:creationId xmlns:a16="http://schemas.microsoft.com/office/drawing/2014/main" id="{467E753C-0BEE-483A-B454-55D88153AE6E}"/>
               </a:ext>
             </a:extLst>
           </p:cNvPr>
@@ -2609,7 +2609,7 @@
           <p:cNvPr id="2" name="Left column">
             <a:extLst xmlns:a="http://schemas.openxmlformats.org/drawingml/2006/main">
               <a:ext uri="{FF2B5EF4-FFF2-40B4-BE49-F238E27FC236}">
-                <a16:creationId xmlns:a16="http://schemas.microsoft.com/office/drawing/2014/main" id="{191C3781-10DA-43D6-B81F-D061275A7CA5}"/>
+                <a16:creationId xmlns:a16="http://schemas.microsoft.com/office/drawing/2014/main" id="{FE1D52CC-938C-4680-88C3-8E238C7C1EA0}"/>
               </a:ext>
             </a:extLst>
           </p:cNvPr>
@@ -2804,12 +2804,12 @@
   </p:cSld>
   <p:clrMap bg1="lt1" tx1="dk1" bg2="lt2" tx2="dk2" accent1="accent1" accent2="accent2" accent3="accent3" accent4="accent4" accent5="accent5" accent6="accent6" hlink="hlink" folHlink="folHlink"/>
   <p:sldLayoutIdLst>
-    <p:sldLayoutId xmlns:r="http://schemas.openxmlformats.org/officeDocument/2006/relationships" id="2147483649" r:id="Rb7932dc056eb4d75"/>
-    <p:sldLayoutId xmlns:r="http://schemas.openxmlformats.org/officeDocument/2006/relationships" id="2147483650" r:id="R9db30c15429d45a2"/>
-    <p:sldLayoutId xmlns:r="http://schemas.openxmlformats.org/officeDocument/2006/relationships" id="2147483651" r:id="R3d8b606083894bbd"/>
-    <p:sldLayoutId xmlns:r="http://schemas.openxmlformats.org/officeDocument/2006/relationships" id="2147483652" r:id="R9ac7383850454d03"/>
-    <p:sldLayoutId xmlns:r="http://schemas.openxmlformats.org/officeDocument/2006/relationships" id="2147483653" r:id="R5a514ed950ff4263"/>
-    <p:sldLayoutId xmlns:r="http://schemas.openxmlformats.org/officeDocument/2006/relationships" id="2147483654" r:id="R3b99b17aafd04f09"/>
+    <p:sldLayoutId xmlns:r="http://schemas.openxmlformats.org/officeDocument/2006/relationships" id="2147483649" r:id="Rca98c8320c424e3e"/>
+    <p:sldLayoutId xmlns:r="http://schemas.openxmlformats.org/officeDocument/2006/relationships" id="2147483650" r:id="Rb6ea51c4422f49f2"/>
+    <p:sldLayoutId xmlns:r="http://schemas.openxmlformats.org/officeDocument/2006/relationships" id="2147483651" r:id="Rfe51c785d3b741e3"/>
+    <p:sldLayoutId xmlns:r="http://schemas.openxmlformats.org/officeDocument/2006/relationships" id="2147483652" r:id="R5cc70baa6d0f4d23"/>
+    <p:sldLayoutId xmlns:r="http://schemas.openxmlformats.org/officeDocument/2006/relationships" id="2147483653" r:id="R5633d3f419324360"/>
+    <p:sldLayoutId xmlns:r="http://schemas.openxmlformats.org/officeDocument/2006/relationships" id="2147483654" r:id="Rf130a1b7ebaf4503"/>
   </p:sldLayoutIdLst>
   <p:txStyles>
     <p:titleStyle>
@@ -3360,7 +3360,7 @@
           <p:cNvPr id="5" name="">
             <a:extLst xmlns:a="http://schemas.openxmlformats.org/drawingml/2006/main">
               <a:ext uri="{FF2B5EF4-FFF2-40B4-BE49-F238E27FC236}">
-                <a16:creationId xmlns:a16="http://schemas.microsoft.com/office/drawing/2014/main" id="{90E73E7F-EC18-41C8-ADB2-462B2BC50CA1}"/>
+                <a16:creationId xmlns:a16="http://schemas.microsoft.com/office/drawing/2014/main" id="{DDABA376-74CC-4CF3-9357-76D4F20D1912}"/>
               </a:ext>
             </a:extLst>
           </p:cNvPr>
@@ -3428,7 +3428,7 @@
           <p:cNvPr id="2" name="">
             <a:extLst xmlns:a="http://schemas.openxmlformats.org/drawingml/2006/main">
               <a:ext uri="{FF2B5EF4-FFF2-40B4-BE49-F238E27FC236}">
-                <a16:creationId xmlns:a16="http://schemas.microsoft.com/office/drawing/2014/main" id="{BFB3DB8B-175D-4196-AF37-A966B299B1F1}"/>
+                <a16:creationId xmlns:a16="http://schemas.microsoft.com/office/drawing/2014/main" id="{BC7B3513-E205-4595-B1EE-451641D72220}"/>
               </a:ext>
             </a:extLst>
           </p:cNvPr>
@@ -3519,7 +3519,7 @@
           <p:cNvPr id="3" name="">
             <a:extLst xmlns:a="http://schemas.openxmlformats.org/drawingml/2006/main">
               <a:ext uri="{FF2B5EF4-FFF2-40B4-BE49-F238E27FC236}">
-                <a16:creationId xmlns:a16="http://schemas.microsoft.com/office/drawing/2014/main" id="{3B9C64FD-A3A8-4954-B142-45B6CDCAB936}"/>
+                <a16:creationId xmlns:a16="http://schemas.microsoft.com/office/drawing/2014/main" id="{2079361C-027B-4805-953C-6EA3282441C0}"/>
               </a:ext>
             </a:extLst>
           </p:cNvPr>
@@ -3610,7 +3610,7 @@
           <p:cNvPr id="4" name="">
             <a:extLst xmlns:a="http://schemas.openxmlformats.org/drawingml/2006/main">
               <a:ext uri="{FF2B5EF4-FFF2-40B4-BE49-F238E27FC236}">
-                <a16:creationId xmlns:a16="http://schemas.microsoft.com/office/drawing/2014/main" id="{3F9F6AA3-A637-4140-A476-1D3158C589A7}"/>
+                <a16:creationId xmlns:a16="http://schemas.microsoft.com/office/drawing/2014/main" id="{7F62ED63-B71A-42A9-8DAC-F117A9AE7687}"/>
               </a:ext>
             </a:extLst>
           </p:cNvPr>
@@ -3699,7 +3699,7 @@
     </p:spTree>
     <p:extLst>
       <p:ext uri="{BB962C8B-B14F-4D97-AF65-F5344CB8AC3E}">
-        <p14:creationId xmlns:p14="http://schemas.microsoft.com/office/powerpoint/2010/main" val="688566134"/>
+        <p14:creationId xmlns:p14="http://schemas.microsoft.com/office/powerpoint/2010/main" val="1801671546"/>
       </p:ext>
     </p:extLst>
   </p:cSld>
@@ -3730,7 +3730,7 @@
           <p:cNvPr id="10" name="">
             <a:extLst xmlns:a="http://schemas.openxmlformats.org/drawingml/2006/main">
               <a:ext uri="{FF2B5EF4-FFF2-40B4-BE49-F238E27FC236}">
-                <a16:creationId xmlns:a16="http://schemas.microsoft.com/office/drawing/2014/main" id="{1A335D93-4475-4AC7-83DA-32D77D32FE2E}"/>
+                <a16:creationId xmlns:a16="http://schemas.microsoft.com/office/drawing/2014/main" id="{EC33170A-330F-4976-918B-B7E3C2AE8AE6}"/>
               </a:ext>
             </a:extLst>
           </p:cNvPr>
@@ -3798,7 +3798,7 @@
           <p:cNvPr id="2" name="">
             <a:extLst xmlns:a="http://schemas.openxmlformats.org/drawingml/2006/main">
               <a:ext uri="{FF2B5EF4-FFF2-40B4-BE49-F238E27FC236}">
-                <a16:creationId xmlns:a16="http://schemas.microsoft.com/office/drawing/2014/main" id="{739421CF-6AE0-457D-A837-8412522E80C7}"/>
+                <a16:creationId xmlns:a16="http://schemas.microsoft.com/office/drawing/2014/main" id="{4B980530-B0F9-425F-886D-905AF71451F0}"/>
               </a:ext>
             </a:extLst>
           </p:cNvPr>
@@ -3866,7 +3866,7 @@
           <p:cNvPr id="3" name="">
             <a:extLst xmlns:a="http://schemas.openxmlformats.org/drawingml/2006/main">
               <a:ext uri="{FF2B5EF4-FFF2-40B4-BE49-F238E27FC236}">
-                <a16:creationId xmlns:a16="http://schemas.microsoft.com/office/drawing/2014/main" id="{BD2254AC-8140-4434-A3B0-189CAE9B2D18}"/>
+                <a16:creationId xmlns:a16="http://schemas.microsoft.com/office/drawing/2014/main" id="{C94B31B7-29FF-4350-9DDB-8043340FA83E}"/>
               </a:ext>
             </a:extLst>
           </p:cNvPr>
@@ -3923,7 +3923,7 @@
                 <a:latin typeface="Arial"/>
                 <a:ea typeface="Arial"/>
                 <a:cs typeface="Arial"/>
-                <a:hlinkClick xmlns:r="http://schemas.openxmlformats.org/officeDocument/2006/relationships" r:id="R7ec36e8f76254b78"/>
+                <a:hlinkClick xmlns:r="http://schemas.openxmlformats.org/officeDocument/2006/relationships" r:id="R6de3dbf51569416b"/>
               </a:rPr>
               <a:t>krackenhell.github.io/oplata-vovremya</a:t>
             </a:r>
@@ -3935,7 +3935,7 @@
           <p:cNvPr id="4" name="">
             <a:extLst xmlns:a="http://schemas.openxmlformats.org/drawingml/2006/main">
               <a:ext uri="{FF2B5EF4-FFF2-40B4-BE49-F238E27FC236}">
-                <a16:creationId xmlns:a16="http://schemas.microsoft.com/office/drawing/2014/main" id="{C9744A1B-7E3D-458C-BEE7-B155AACB087C}"/>
+                <a16:creationId xmlns:a16="http://schemas.microsoft.com/office/drawing/2014/main" id="{5222790B-E15B-455E-80AB-C77B623AA64E}"/>
               </a:ext>
             </a:extLst>
           </p:cNvPr>
@@ -4003,7 +4003,7 @@
           <p:cNvPr id="5" name="">
             <a:extLst xmlns:a="http://schemas.openxmlformats.org/drawingml/2006/main">
               <a:ext uri="{FF2B5EF4-FFF2-40B4-BE49-F238E27FC236}">
-                <a16:creationId xmlns:a16="http://schemas.microsoft.com/office/drawing/2014/main" id="{4FF1FCCA-E317-4C38-AB3A-FD2A7E991E93}"/>
+                <a16:creationId xmlns:a16="http://schemas.microsoft.com/office/drawing/2014/main" id="{2C3FD262-25C6-4D3D-A122-04A6E4DA35FD}"/>
               </a:ext>
             </a:extLst>
           </p:cNvPr>
@@ -4071,7 +4071,7 @@
           <p:cNvPr id="6" name="">
             <a:extLst xmlns:a="http://schemas.openxmlformats.org/drawingml/2006/main">
               <a:ext uri="{FF2B5EF4-FFF2-40B4-BE49-F238E27FC236}">
-                <a16:creationId xmlns:a16="http://schemas.microsoft.com/office/drawing/2014/main" id="{AE24384B-885C-4B6F-A7FD-7EEAA038D456}"/>
+                <a16:creationId xmlns:a16="http://schemas.microsoft.com/office/drawing/2014/main" id="{B1FFCBCA-C84D-424C-B64D-9F7BD4F21E9E}"/>
               </a:ext>
             </a:extLst>
           </p:cNvPr>
@@ -4083,7 +4083,7 @@
         <p:spPr>
           <a:xfrm xmlns:a="http://schemas.openxmlformats.org/drawingml/2006/main">
             <a:off x="7429500" y="3438525"/>
-            <a:ext cx="3810000" cy="523875"/>
+            <a:ext cx="4000500" cy="523875"/>
           </a:xfrm>
           <a:prstGeom xmlns:a="http://schemas.openxmlformats.org/drawingml/2006/main" prst="rect">
             <a:avLst/>
@@ -4129,7 +4129,7 @@
                 <a:ea typeface="Arial"/>
                 <a:cs typeface="Arial"/>
               </a:rPr>
-              <a:t>Михаил</a:t>
+              <a:t>Михаил Дементьев</a:t>
             </a:r>
           </a:p>
         </p:txBody>
@@ -4139,7 +4139,7 @@
           <p:cNvPr id="7" name="">
             <a:extLst xmlns:a="http://schemas.openxmlformats.org/drawingml/2006/main">
               <a:ext uri="{FF2B5EF4-FFF2-40B4-BE49-F238E27FC236}">
-                <a16:creationId xmlns:a16="http://schemas.microsoft.com/office/drawing/2014/main" id="{8F8A9C1A-997C-4AFA-A918-9D9A26A56B21}"/>
+                <a16:creationId xmlns:a16="http://schemas.microsoft.com/office/drawing/2014/main" id="{0169158D-581F-4EAB-981B-E8EACCA41450}"/>
               </a:ext>
             </a:extLst>
           </p:cNvPr>
@@ -4230,7 +4230,7 @@
           <p:cNvPr id="8" name="">
             <a:extLst xmlns:a="http://schemas.openxmlformats.org/drawingml/2006/main">
               <a:ext uri="{FF2B5EF4-FFF2-40B4-BE49-F238E27FC236}">
-                <a16:creationId xmlns:a16="http://schemas.microsoft.com/office/drawing/2014/main" id="{6CA85F95-61AC-48F7-98DD-74D55AF3FCBB}"/>
+                <a16:creationId xmlns:a16="http://schemas.microsoft.com/office/drawing/2014/main" id="{0BE1C2BF-5EC9-4AD2-B6D6-1A20BDFF57B0}"/>
               </a:ext>
             </a:extLst>
           </p:cNvPr>
@@ -4241,8 +4241,8 @@
         </p:nvSpPr>
         <p:spPr>
           <a:xfrm xmlns:a="http://schemas.openxmlformats.org/drawingml/2006/main">
-            <a:off x="742950" y="5381625"/>
-            <a:ext cx="9525000" cy="381000"/>
+            <a:off x="742950" y="4810125"/>
+            <a:ext cx="6191250" cy="714375"/>
           </a:xfrm>
           <a:prstGeom xmlns:a="http://schemas.openxmlformats.org/drawingml/2006/main" prst="rect">
             <a:avLst/>
@@ -4288,7 +4288,30 @@
                 <a:ea typeface="Arial"/>
                 <a:cs typeface="Arial"/>
               </a:rPr>
-              <a:t>Магистранты ТИУ</a:t>
+              <a:t>ВШЭ · Финансовые рынки</a:t>
+            </a:r>
+          </a:p>
+          <a:p xmlns:a="http://schemas.openxmlformats.org/drawingml/2006/main">
+            <a:pPr>
+              <a:defRPr sz="1800" b="0">
+                <a:solidFill>
+                  <a:srgbClr val="B7C8BD"/>
+                </a:solidFill>
+                <a:latin typeface="Arial"/>
+                <a:ea typeface="Arial"/>
+                <a:cs typeface="Arial"/>
+              </a:defRPr>
+            </a:pPr>
+            <a:r>
+              <a:rPr sz="1800" b="0">
+                <a:solidFill>
+                  <a:srgbClr val="B7C8BD"/>
+                </a:solidFill>
+                <a:latin typeface="Arial"/>
+                <a:ea typeface="Arial"/>
+                <a:cs typeface="Arial"/>
+              </a:rPr>
+              <a:t>и финансовые институты</a:t>
             </a:r>
           </a:p>
         </p:txBody>
@@ -4298,7 +4321,7 @@
           <p:cNvPr id="9" name="">
             <a:extLst xmlns:a="http://schemas.openxmlformats.org/drawingml/2006/main">
               <a:ext uri="{FF2B5EF4-FFF2-40B4-BE49-F238E27FC236}">
-                <a16:creationId xmlns:a16="http://schemas.microsoft.com/office/drawing/2014/main" id="{FCD8AD6C-C534-4D0B-8DE0-A6C10B44161F}"/>
+                <a16:creationId xmlns:a16="http://schemas.microsoft.com/office/drawing/2014/main" id="{C58D3824-8A08-4437-A972-7FB2EAEEEA9B}"/>
               </a:ext>
             </a:extLst>
           </p:cNvPr>
@@ -4364,7 +4387,7 @@
     </p:spTree>
     <p:extLst>
       <p:ext uri="{BB962C8B-B14F-4D97-AF65-F5344CB8AC3E}">
-        <p14:creationId xmlns:p14="http://schemas.microsoft.com/office/powerpoint/2010/main" val="1468196120"/>
+        <p14:creationId xmlns:p14="http://schemas.microsoft.com/office/powerpoint/2010/main" val="799388512"/>
       </p:ext>
     </p:extLst>
   </p:cSld>
@@ -4395,7 +4418,7 @@
           <p:cNvPr id="8" name="">
             <a:extLst xmlns:a="http://schemas.openxmlformats.org/drawingml/2006/main">
               <a:ext uri="{FF2B5EF4-FFF2-40B4-BE49-F238E27FC236}">
-                <a16:creationId xmlns:a16="http://schemas.microsoft.com/office/drawing/2014/main" id="{9B85264A-9939-4A5A-A8A9-6BF23FC27F60}"/>
+                <a16:creationId xmlns:a16="http://schemas.microsoft.com/office/drawing/2014/main" id="{038C9EB0-6FD8-4985-B545-FFD08BDF3815}"/>
               </a:ext>
             </a:extLst>
           </p:cNvPr>
@@ -4463,7 +4486,7 @@
           <p:cNvPr id="2" name="">
             <a:extLst xmlns:a="http://schemas.openxmlformats.org/drawingml/2006/main">
               <a:ext uri="{FF2B5EF4-FFF2-40B4-BE49-F238E27FC236}">
-                <a16:creationId xmlns:a16="http://schemas.microsoft.com/office/drawing/2014/main" id="{91D31BF4-7214-4FF1-BFE9-448902D85651}"/>
+                <a16:creationId xmlns:a16="http://schemas.microsoft.com/office/drawing/2014/main" id="{144C7988-C5B1-46E5-BAEF-49CE2E11E0AD}"/>
               </a:ext>
             </a:extLst>
           </p:cNvPr>
@@ -4531,7 +4554,7 @@
           <p:cNvPr id="3" name="">
             <a:extLst xmlns:a="http://schemas.openxmlformats.org/drawingml/2006/main">
               <a:ext uri="{FF2B5EF4-FFF2-40B4-BE49-F238E27FC236}">
-                <a16:creationId xmlns:a16="http://schemas.microsoft.com/office/drawing/2014/main" id="{D3E6ED68-6193-4767-9BBE-0B5517B4FAA0}"/>
+                <a16:creationId xmlns:a16="http://schemas.microsoft.com/office/drawing/2014/main" id="{C617903E-1CE6-4A77-B769-5164AB417E9D}"/>
               </a:ext>
             </a:extLst>
           </p:cNvPr>
@@ -4599,7 +4622,7 @@
           <p:cNvPr id="4" name="">
             <a:extLst xmlns:a="http://schemas.openxmlformats.org/drawingml/2006/main">
               <a:ext uri="{FF2B5EF4-FFF2-40B4-BE49-F238E27FC236}">
-                <a16:creationId xmlns:a16="http://schemas.microsoft.com/office/drawing/2014/main" id="{13916853-5C2D-4193-B8CE-6970246F0821}"/>
+                <a16:creationId xmlns:a16="http://schemas.microsoft.com/office/drawing/2014/main" id="{E97B031A-8A11-4E8F-98A6-A788F169EFB3}"/>
               </a:ext>
             </a:extLst>
           </p:cNvPr>
@@ -4713,7 +4736,7 @@
           <p:cNvPr id="5" name="">
             <a:extLst xmlns:a="http://schemas.openxmlformats.org/drawingml/2006/main">
               <a:ext uri="{FF2B5EF4-FFF2-40B4-BE49-F238E27FC236}">
-                <a16:creationId xmlns:a16="http://schemas.microsoft.com/office/drawing/2014/main" id="{AE1F1973-B9BC-40B6-8C8E-C6E1F67685AB}"/>
+                <a16:creationId xmlns:a16="http://schemas.microsoft.com/office/drawing/2014/main" id="{586BCD51-F624-4711-868B-0389443D6694}"/>
               </a:ext>
             </a:extLst>
           </p:cNvPr>
@@ -4781,7 +4804,7 @@
           <p:cNvPr id="6" name="">
             <a:extLst xmlns:a="http://schemas.openxmlformats.org/drawingml/2006/main">
               <a:ext uri="{FF2B5EF4-FFF2-40B4-BE49-F238E27FC236}">
-                <a16:creationId xmlns:a16="http://schemas.microsoft.com/office/drawing/2014/main" id="{F0474F54-B55A-48A2-B27A-056B90E8C9A6}"/>
+                <a16:creationId xmlns:a16="http://schemas.microsoft.com/office/drawing/2014/main" id="{5E320FB0-726E-460B-860C-266B18094675}"/>
               </a:ext>
             </a:extLst>
           </p:cNvPr>
@@ -4872,7 +4895,7 @@
           <p:cNvPr id="7" name="">
             <a:extLst xmlns:a="http://schemas.openxmlformats.org/drawingml/2006/main">
               <a:ext uri="{FF2B5EF4-FFF2-40B4-BE49-F238E27FC236}">
-                <a16:creationId xmlns:a16="http://schemas.microsoft.com/office/drawing/2014/main" id="{857D58E6-11B3-40FE-9D30-02665C57F781}"/>
+                <a16:creationId xmlns:a16="http://schemas.microsoft.com/office/drawing/2014/main" id="{E572BFE0-064F-4CDC-9A0E-533BF71B2166}"/>
               </a:ext>
             </a:extLst>
           </p:cNvPr>
@@ -4938,7 +4961,7 @@
     </p:spTree>
     <p:extLst>
       <p:ext uri="{BB962C8B-B14F-4D97-AF65-F5344CB8AC3E}">
-        <p14:creationId xmlns:p14="http://schemas.microsoft.com/office/powerpoint/2010/main" val="1580236378"/>
+        <p14:creationId xmlns:p14="http://schemas.microsoft.com/office/powerpoint/2010/main" val="398404127"/>
       </p:ext>
     </p:extLst>
   </p:cSld>
@@ -4969,7 +4992,7 @@
           <p:cNvPr id="9" name="">
             <a:extLst xmlns:a="http://schemas.openxmlformats.org/drawingml/2006/main">
               <a:ext uri="{FF2B5EF4-FFF2-40B4-BE49-F238E27FC236}">
-                <a16:creationId xmlns:a16="http://schemas.microsoft.com/office/drawing/2014/main" id="{EB310101-6A7E-4A95-92BE-027BD329E190}"/>
+                <a16:creationId xmlns:a16="http://schemas.microsoft.com/office/drawing/2014/main" id="{81D51B34-E08D-49C8-A9B3-06E61CCFE797}"/>
               </a:ext>
             </a:extLst>
           </p:cNvPr>
@@ -5037,7 +5060,7 @@
           <p:cNvPr id="2" name="">
             <a:extLst xmlns:a="http://schemas.openxmlformats.org/drawingml/2006/main">
               <a:ext uri="{FF2B5EF4-FFF2-40B4-BE49-F238E27FC236}">
-                <a16:creationId xmlns:a16="http://schemas.microsoft.com/office/drawing/2014/main" id="{B8638C73-1D70-416E-A103-C1106A3F7F11}"/>
+                <a16:creationId xmlns:a16="http://schemas.microsoft.com/office/drawing/2014/main" id="{723FA529-4FFE-4624-A909-F622EBBB35E4}"/>
               </a:ext>
             </a:extLst>
           </p:cNvPr>
@@ -5105,7 +5128,7 @@
           <p:cNvPr id="3" name="">
             <a:extLst xmlns:a="http://schemas.openxmlformats.org/drawingml/2006/main">
               <a:ext uri="{FF2B5EF4-FFF2-40B4-BE49-F238E27FC236}">
-                <a16:creationId xmlns:a16="http://schemas.microsoft.com/office/drawing/2014/main" id="{41EA68B5-A8E1-4E48-81F0-2168A74A83F9}"/>
+                <a16:creationId xmlns:a16="http://schemas.microsoft.com/office/drawing/2014/main" id="{DAD83D82-F3AB-4AEB-A3F9-AC1557EF862C}"/>
               </a:ext>
             </a:extLst>
           </p:cNvPr>
@@ -5196,7 +5219,7 @@
           <p:cNvPr id="4" name="">
             <a:extLst xmlns:a="http://schemas.openxmlformats.org/drawingml/2006/main">
               <a:ext uri="{FF2B5EF4-FFF2-40B4-BE49-F238E27FC236}">
-                <a16:creationId xmlns:a16="http://schemas.microsoft.com/office/drawing/2014/main" id="{E60C34D7-03FC-4699-AC03-954C8C9780C9}"/>
+                <a16:creationId xmlns:a16="http://schemas.microsoft.com/office/drawing/2014/main" id="{4B1366EF-FD2D-4ED9-B306-5D2353B92AF1}"/>
               </a:ext>
             </a:extLst>
           </p:cNvPr>
@@ -5310,7 +5333,7 @@
           <p:cNvPr id="5" name="">
             <a:extLst xmlns:a="http://schemas.openxmlformats.org/drawingml/2006/main">
               <a:ext uri="{FF2B5EF4-FFF2-40B4-BE49-F238E27FC236}">
-                <a16:creationId xmlns:a16="http://schemas.microsoft.com/office/drawing/2014/main" id="{2A38525B-B10E-4E8C-9319-2CC23856DD87}"/>
+                <a16:creationId xmlns:a16="http://schemas.microsoft.com/office/drawing/2014/main" id="{35286D28-F2E8-4F37-8D3F-FF1628F0A010}"/>
               </a:ext>
             </a:extLst>
           </p:cNvPr>
@@ -5378,7 +5401,7 @@
           <p:cNvPr id="6" name="">
             <a:extLst xmlns:a="http://schemas.openxmlformats.org/drawingml/2006/main">
               <a:ext uri="{FF2B5EF4-FFF2-40B4-BE49-F238E27FC236}">
-                <a16:creationId xmlns:a16="http://schemas.microsoft.com/office/drawing/2014/main" id="{41099C51-DF59-4CD2-9560-8D947D295FFC}"/>
+                <a16:creationId xmlns:a16="http://schemas.microsoft.com/office/drawing/2014/main" id="{0B1F72E5-A088-4851-9536-263087488146}"/>
               </a:ext>
             </a:extLst>
           </p:cNvPr>
@@ -5446,7 +5469,7 @@
           <p:cNvPr id="7" name="">
             <a:extLst xmlns:a="http://schemas.openxmlformats.org/drawingml/2006/main">
               <a:ext uri="{FF2B5EF4-FFF2-40B4-BE49-F238E27FC236}">
-                <a16:creationId xmlns:a16="http://schemas.microsoft.com/office/drawing/2014/main" id="{F43ADC1E-FEC3-4B22-91C9-3587137254A0}"/>
+                <a16:creationId xmlns:a16="http://schemas.microsoft.com/office/drawing/2014/main" id="{291C3743-12E5-40D3-8E2D-B5F661A1EF90}"/>
               </a:ext>
             </a:extLst>
           </p:cNvPr>
@@ -5514,7 +5537,7 @@
           <p:cNvPr id="8" name="">
             <a:extLst xmlns:a="http://schemas.openxmlformats.org/drawingml/2006/main">
               <a:ext uri="{FF2B5EF4-FFF2-40B4-BE49-F238E27FC236}">
-                <a16:creationId xmlns:a16="http://schemas.microsoft.com/office/drawing/2014/main" id="{69604CBC-330B-4C27-85FB-BC50E948FCDB}"/>
+                <a16:creationId xmlns:a16="http://schemas.microsoft.com/office/drawing/2014/main" id="{41724F37-3F4E-4D7A-B062-A9CCB9F1230B}"/>
               </a:ext>
             </a:extLst>
           </p:cNvPr>
@@ -5603,7 +5626,7 @@
     </p:spTree>
     <p:extLst>
       <p:ext uri="{BB962C8B-B14F-4D97-AF65-F5344CB8AC3E}">
-        <p14:creationId xmlns:p14="http://schemas.microsoft.com/office/powerpoint/2010/main" val="201350902"/>
+        <p14:creationId xmlns:p14="http://schemas.microsoft.com/office/powerpoint/2010/main" val="372128469"/>
       </p:ext>
     </p:extLst>
   </p:cSld>
@@ -5634,7 +5657,7 @@
           <p:cNvPr id="8" name="">
             <a:extLst xmlns:a="http://schemas.openxmlformats.org/drawingml/2006/main">
               <a:ext uri="{FF2B5EF4-FFF2-40B4-BE49-F238E27FC236}">
-                <a16:creationId xmlns:a16="http://schemas.microsoft.com/office/drawing/2014/main" id="{78EF5E3A-5003-496C-9DE3-9FCD5D49F0FB}"/>
+                <a16:creationId xmlns:a16="http://schemas.microsoft.com/office/drawing/2014/main" id="{316FAF71-EFCF-4290-992F-61076D979B92}"/>
               </a:ext>
             </a:extLst>
           </p:cNvPr>
@@ -5702,7 +5725,7 @@
           <p:cNvPr id="2" name="">
             <a:extLst xmlns:a="http://schemas.openxmlformats.org/drawingml/2006/main">
               <a:ext uri="{FF2B5EF4-FFF2-40B4-BE49-F238E27FC236}">
-                <a16:creationId xmlns:a16="http://schemas.microsoft.com/office/drawing/2014/main" id="{8160C323-B38E-4F31-B9F2-76AF825B6C9B}"/>
+                <a16:creationId xmlns:a16="http://schemas.microsoft.com/office/drawing/2014/main" id="{14A27142-E411-4263-937C-99A9364CC53D}"/>
               </a:ext>
             </a:extLst>
           </p:cNvPr>
@@ -5770,7 +5793,7 @@
           <p:cNvPr id="3" name="">
             <a:extLst xmlns:a="http://schemas.openxmlformats.org/drawingml/2006/main">
               <a:ext uri="{FF2B5EF4-FFF2-40B4-BE49-F238E27FC236}">
-                <a16:creationId xmlns:a16="http://schemas.microsoft.com/office/drawing/2014/main" id="{DE889022-452E-4579-8A81-926E69BE52F9}"/>
+                <a16:creationId xmlns:a16="http://schemas.microsoft.com/office/drawing/2014/main" id="{7983BAD5-B887-44BF-9034-F16B7D13A37D}"/>
               </a:ext>
             </a:extLst>
           </p:cNvPr>
@@ -5780,7 +5803,7 @@
           <p:nvPr/>
         </p:nvPicPr>
         <p:blipFill>
-          <a:blip xmlns:r="http://schemas.openxmlformats.org/officeDocument/2006/relationships" xmlns:a="http://schemas.openxmlformats.org/drawingml/2006/main" r:embed="R20cd6f7783cd4da0"/>
+          <a:blip xmlns:r="http://schemas.openxmlformats.org/officeDocument/2006/relationships" xmlns:a="http://schemas.openxmlformats.org/drawingml/2006/main" r:embed="R8e28761c82a44653"/>
           <a:stretch xmlns:a="http://schemas.openxmlformats.org/drawingml/2006/main"/>
         </p:blipFill>
         <p:spPr>
@@ -5798,7 +5821,7 @@
           <p:cNvPr id="4" name="">
             <a:extLst xmlns:a="http://schemas.openxmlformats.org/drawingml/2006/main">
               <a:ext uri="{FF2B5EF4-FFF2-40B4-BE49-F238E27FC236}">
-                <a16:creationId xmlns:a16="http://schemas.microsoft.com/office/drawing/2014/main" id="{59B008DF-019F-4CFC-AF4B-8395FF27A23E}"/>
+                <a16:creationId xmlns:a16="http://schemas.microsoft.com/office/drawing/2014/main" id="{0FF55083-59A3-4054-8474-4D450FA66195}"/>
               </a:ext>
             </a:extLst>
           </p:cNvPr>
@@ -5866,7 +5889,7 @@
           <p:cNvPr id="5" name="">
             <a:extLst xmlns:a="http://schemas.openxmlformats.org/drawingml/2006/main">
               <a:ext uri="{FF2B5EF4-FFF2-40B4-BE49-F238E27FC236}">
-                <a16:creationId xmlns:a16="http://schemas.microsoft.com/office/drawing/2014/main" id="{B0F95364-402B-4CFD-A504-C60F7FFE5BB5}"/>
+                <a16:creationId xmlns:a16="http://schemas.microsoft.com/office/drawing/2014/main" id="{3212F34F-DE51-4392-868F-1E249E641DAD}"/>
               </a:ext>
             </a:extLst>
           </p:cNvPr>
@@ -5957,7 +5980,7 @@
           <p:cNvPr id="6" name="">
             <a:extLst xmlns:a="http://schemas.openxmlformats.org/drawingml/2006/main">
               <a:ext uri="{FF2B5EF4-FFF2-40B4-BE49-F238E27FC236}">
-                <a16:creationId xmlns:a16="http://schemas.microsoft.com/office/drawing/2014/main" id="{D0CB4018-EC77-421D-BDE7-99F4E7426670}"/>
+                <a16:creationId xmlns:a16="http://schemas.microsoft.com/office/drawing/2014/main" id="{85FEB629-343E-4ECA-BA18-D67592E345CC}"/>
               </a:ext>
             </a:extLst>
           </p:cNvPr>
@@ -6048,7 +6071,7 @@
           <p:cNvPr id="7" name="">
             <a:extLst xmlns:a="http://schemas.openxmlformats.org/drawingml/2006/main">
               <a:ext uri="{FF2B5EF4-FFF2-40B4-BE49-F238E27FC236}">
-                <a16:creationId xmlns:a16="http://schemas.microsoft.com/office/drawing/2014/main" id="{ACC7B49E-3B44-4CDB-8BE5-FD9E522DEE3C}"/>
+                <a16:creationId xmlns:a16="http://schemas.microsoft.com/office/drawing/2014/main" id="{E29DF1E7-9E3F-4102-9904-378BC4CF51E6}"/>
               </a:ext>
             </a:extLst>
           </p:cNvPr>
@@ -6137,7 +6160,7 @@
     </p:spTree>
     <p:extLst>
       <p:ext uri="{BB962C8B-B14F-4D97-AF65-F5344CB8AC3E}">
-        <p14:creationId xmlns:p14="http://schemas.microsoft.com/office/powerpoint/2010/main" val="1818850939"/>
+        <p14:creationId xmlns:p14="http://schemas.microsoft.com/office/powerpoint/2010/main" val="148596498"/>
       </p:ext>
     </p:extLst>
   </p:cSld>
@@ -6168,7 +6191,7 @@
           <p:cNvPr id="9" name="">
             <a:extLst xmlns:a="http://schemas.openxmlformats.org/drawingml/2006/main">
               <a:ext uri="{FF2B5EF4-FFF2-40B4-BE49-F238E27FC236}">
-                <a16:creationId xmlns:a16="http://schemas.microsoft.com/office/drawing/2014/main" id="{3487BF20-2DE2-47CD-8BB2-92422CBB16A4}"/>
+                <a16:creationId xmlns:a16="http://schemas.microsoft.com/office/drawing/2014/main" id="{3AF5CA80-35D3-419A-BCD3-3AC6E4A09013}"/>
               </a:ext>
             </a:extLst>
           </p:cNvPr>
@@ -6236,7 +6259,7 @@
           <p:cNvPr id="2" name="">
             <a:extLst xmlns:a="http://schemas.openxmlformats.org/drawingml/2006/main">
               <a:ext uri="{FF2B5EF4-FFF2-40B4-BE49-F238E27FC236}">
-                <a16:creationId xmlns:a16="http://schemas.microsoft.com/office/drawing/2014/main" id="{EEF05B07-F5BE-454D-8954-4A19E7C8A3E2}"/>
+                <a16:creationId xmlns:a16="http://schemas.microsoft.com/office/drawing/2014/main" id="{902CD8FF-E2CC-4D03-9DBB-30A90EFAC3FB}"/>
               </a:ext>
             </a:extLst>
           </p:cNvPr>
@@ -6304,7 +6327,7 @@
           <p:cNvPr id="3" name="">
             <a:extLst xmlns:a="http://schemas.openxmlformats.org/drawingml/2006/main">
               <a:ext uri="{FF2B5EF4-FFF2-40B4-BE49-F238E27FC236}">
-                <a16:creationId xmlns:a16="http://schemas.microsoft.com/office/drawing/2014/main" id="{8544F720-7072-43FF-B5AD-52F0AC309DCD}"/>
+                <a16:creationId xmlns:a16="http://schemas.microsoft.com/office/drawing/2014/main" id="{B458F07C-890F-4D38-A7DA-1090A98873D0}"/>
               </a:ext>
             </a:extLst>
           </p:cNvPr>
@@ -6372,7 +6395,7 @@
           <p:cNvPr id="4" name="">
             <a:extLst xmlns:a="http://schemas.openxmlformats.org/drawingml/2006/main">
               <a:ext uri="{FF2B5EF4-FFF2-40B4-BE49-F238E27FC236}">
-                <a16:creationId xmlns:a16="http://schemas.microsoft.com/office/drawing/2014/main" id="{0BF830E2-F24F-45E8-B044-B0F19075766C}"/>
+                <a16:creationId xmlns:a16="http://schemas.microsoft.com/office/drawing/2014/main" id="{EC73D58C-05A9-42CE-A489-71BDC44D2B7D}"/>
               </a:ext>
             </a:extLst>
           </p:cNvPr>
@@ -6440,7 +6463,7 @@
           <p:cNvPr id="5" name="">
             <a:extLst xmlns:a="http://schemas.openxmlformats.org/drawingml/2006/main">
               <a:ext uri="{FF2B5EF4-FFF2-40B4-BE49-F238E27FC236}">
-                <a16:creationId xmlns:a16="http://schemas.microsoft.com/office/drawing/2014/main" id="{B8E3135A-E2A7-4B28-9DDC-1F02447615B4}"/>
+                <a16:creationId xmlns:a16="http://schemas.microsoft.com/office/drawing/2014/main" id="{D68D3B5B-5B05-4CCB-B952-17E5840F62DF}"/>
               </a:ext>
             </a:extLst>
           </p:cNvPr>
@@ -6531,7 +6554,7 @@
           <p:cNvPr id="6" name="">
             <a:extLst xmlns:a="http://schemas.openxmlformats.org/drawingml/2006/main">
               <a:ext uri="{FF2B5EF4-FFF2-40B4-BE49-F238E27FC236}">
-                <a16:creationId xmlns:a16="http://schemas.microsoft.com/office/drawing/2014/main" id="{0C309269-6C3F-42FE-A809-46367FA7947E}"/>
+                <a16:creationId xmlns:a16="http://schemas.microsoft.com/office/drawing/2014/main" id="{CDFB1D00-EA68-4677-B6A1-7131C935C188}"/>
               </a:ext>
             </a:extLst>
           </p:cNvPr>
@@ -6599,7 +6622,7 @@
           <p:cNvPr id="7" name="">
             <a:extLst xmlns:a="http://schemas.openxmlformats.org/drawingml/2006/main">
               <a:ext uri="{FF2B5EF4-FFF2-40B4-BE49-F238E27FC236}">
-                <a16:creationId xmlns:a16="http://schemas.microsoft.com/office/drawing/2014/main" id="{A354E018-8CDF-4CC3-B051-53D6C9233F35}"/>
+                <a16:creationId xmlns:a16="http://schemas.microsoft.com/office/drawing/2014/main" id="{59D1F6DC-3D40-4C41-BEF3-BC6317AD33A4}"/>
               </a:ext>
             </a:extLst>
           </p:cNvPr>
@@ -6667,7 +6690,7 @@
           <p:cNvPr id="8" name="">
             <a:extLst xmlns:a="http://schemas.openxmlformats.org/drawingml/2006/main">
               <a:ext uri="{FF2B5EF4-FFF2-40B4-BE49-F238E27FC236}">
-                <a16:creationId xmlns:a16="http://schemas.microsoft.com/office/drawing/2014/main" id="{9B0DA25A-4477-4E97-9DEA-5154000F5DFA}"/>
+                <a16:creationId xmlns:a16="http://schemas.microsoft.com/office/drawing/2014/main" id="{F2DC67B6-CCF3-4546-B11B-C45F9CA73EF4}"/>
               </a:ext>
             </a:extLst>
           </p:cNvPr>
@@ -6677,7 +6700,7 @@
           <p:nvPr/>
         </p:nvPicPr>
         <p:blipFill>
-          <a:blip xmlns:r="http://schemas.openxmlformats.org/officeDocument/2006/relationships" xmlns:a="http://schemas.openxmlformats.org/drawingml/2006/main" r:embed="R720fb7a39f414cb0"/>
+          <a:blip xmlns:r="http://schemas.openxmlformats.org/officeDocument/2006/relationships" xmlns:a="http://schemas.openxmlformats.org/drawingml/2006/main" r:embed="Rcde94cf21ec34616"/>
           <a:stretch xmlns:a="http://schemas.openxmlformats.org/drawingml/2006/main"/>
         </p:blipFill>
         <p:spPr>
@@ -6693,7 +6716,7 @@
     </p:spTree>
     <p:extLst>
       <p:ext uri="{BB962C8B-B14F-4D97-AF65-F5344CB8AC3E}">
-        <p14:creationId xmlns:p14="http://schemas.microsoft.com/office/powerpoint/2010/main" val="852522149"/>
+        <p14:creationId xmlns:p14="http://schemas.microsoft.com/office/powerpoint/2010/main" val="707279721"/>
       </p:ext>
     </p:extLst>
   </p:cSld>
@@ -6724,7 +6747,7 @@
           <p:cNvPr id="8" name="">
             <a:extLst xmlns:a="http://schemas.openxmlformats.org/drawingml/2006/main">
               <a:ext uri="{FF2B5EF4-FFF2-40B4-BE49-F238E27FC236}">
-                <a16:creationId xmlns:a16="http://schemas.microsoft.com/office/drawing/2014/main" id="{C9DCB4FE-6B4C-4250-AD96-E16140E50E4D}"/>
+                <a16:creationId xmlns:a16="http://schemas.microsoft.com/office/drawing/2014/main" id="{D6F5EAEC-0ABB-4B9A-8DCA-A2014E74ACDC}"/>
               </a:ext>
             </a:extLst>
           </p:cNvPr>
@@ -6792,7 +6815,7 @@
           <p:cNvPr id="2" name="">
             <a:extLst xmlns:a="http://schemas.openxmlformats.org/drawingml/2006/main">
               <a:ext uri="{FF2B5EF4-FFF2-40B4-BE49-F238E27FC236}">
-                <a16:creationId xmlns:a16="http://schemas.microsoft.com/office/drawing/2014/main" id="{35A0B69E-BE89-4347-9621-6F966937DC1F}"/>
+                <a16:creationId xmlns:a16="http://schemas.microsoft.com/office/drawing/2014/main" id="{09B069A2-997A-462C-8E29-799DAD2D7313}"/>
               </a:ext>
             </a:extLst>
           </p:cNvPr>
@@ -6860,7 +6883,7 @@
           <p:cNvPr id="3" name="">
             <a:extLst xmlns:a="http://schemas.openxmlformats.org/drawingml/2006/main">
               <a:ext uri="{FF2B5EF4-FFF2-40B4-BE49-F238E27FC236}">
-                <a16:creationId xmlns:a16="http://schemas.microsoft.com/office/drawing/2014/main" id="{90E0925E-AB74-4459-9BE6-AB4CC44B2356}"/>
+                <a16:creationId xmlns:a16="http://schemas.microsoft.com/office/drawing/2014/main" id="{2D793422-4014-4D79-B7AC-EAE2926FF2D9}"/>
               </a:ext>
             </a:extLst>
           </p:cNvPr>
@@ -6928,7 +6951,7 @@
           <p:cNvPr id="4" name="">
             <a:extLst xmlns:a="http://schemas.openxmlformats.org/drawingml/2006/main">
               <a:ext uri="{FF2B5EF4-FFF2-40B4-BE49-F238E27FC236}">
-                <a16:creationId xmlns:a16="http://schemas.microsoft.com/office/drawing/2014/main" id="{42B8CCC0-8C1B-4F1F-8FA3-CCF32B30DB93}"/>
+                <a16:creationId xmlns:a16="http://schemas.microsoft.com/office/drawing/2014/main" id="{85825200-F070-477A-B910-8EA6BCDEBDEE}"/>
               </a:ext>
             </a:extLst>
           </p:cNvPr>
@@ -7088,7 +7111,7 @@
           <p:cNvPr id="5" name="">
             <a:extLst xmlns:a="http://schemas.openxmlformats.org/drawingml/2006/main">
               <a:ext uri="{FF2B5EF4-FFF2-40B4-BE49-F238E27FC236}">
-                <a16:creationId xmlns:a16="http://schemas.microsoft.com/office/drawing/2014/main" id="{C8AF9627-6ECE-4BFB-BAD1-7A67C8DE530A}"/>
+                <a16:creationId xmlns:a16="http://schemas.microsoft.com/office/drawing/2014/main" id="{B8AE5E66-E904-4620-BE56-D080B96F0639}"/>
               </a:ext>
             </a:extLst>
           </p:cNvPr>
@@ -7156,7 +7179,7 @@
           <p:cNvPr id="6" name="">
             <a:extLst xmlns:a="http://schemas.openxmlformats.org/drawingml/2006/main">
               <a:ext uri="{FF2B5EF4-FFF2-40B4-BE49-F238E27FC236}">
-                <a16:creationId xmlns:a16="http://schemas.microsoft.com/office/drawing/2014/main" id="{0724901D-C4E0-4097-A60D-6FDD7E8A19D2}"/>
+                <a16:creationId xmlns:a16="http://schemas.microsoft.com/office/drawing/2014/main" id="{711F76B1-D3A4-4225-95C5-FDE31FE2C19A}"/>
               </a:ext>
             </a:extLst>
           </p:cNvPr>
@@ -7270,7 +7293,7 @@
           <p:cNvPr id="7" name="">
             <a:extLst xmlns:a="http://schemas.openxmlformats.org/drawingml/2006/main">
               <a:ext uri="{FF2B5EF4-FFF2-40B4-BE49-F238E27FC236}">
-                <a16:creationId xmlns:a16="http://schemas.microsoft.com/office/drawing/2014/main" id="{DAE716E8-CB88-48D8-ACC8-2F2B904562D7}"/>
+                <a16:creationId xmlns:a16="http://schemas.microsoft.com/office/drawing/2014/main" id="{153594F3-A8D1-4AAC-B50F-642283226E25}"/>
               </a:ext>
             </a:extLst>
           </p:cNvPr>
@@ -7382,7 +7405,7 @@
     </p:spTree>
     <p:extLst>
       <p:ext uri="{BB962C8B-B14F-4D97-AF65-F5344CB8AC3E}">
-        <p14:creationId xmlns:p14="http://schemas.microsoft.com/office/powerpoint/2010/main" val="154202799"/>
+        <p14:creationId xmlns:p14="http://schemas.microsoft.com/office/powerpoint/2010/main" val="1847924376"/>
       </p:ext>
     </p:extLst>
   </p:cSld>
@@ -7413,7 +7436,7 @@
           <p:cNvPr id="5" name="">
             <a:extLst xmlns:a="http://schemas.openxmlformats.org/drawingml/2006/main">
               <a:ext uri="{FF2B5EF4-FFF2-40B4-BE49-F238E27FC236}">
-                <a16:creationId xmlns:a16="http://schemas.microsoft.com/office/drawing/2014/main" id="{3B063EAA-DD5C-4E68-9EB9-1D46C1C8D7CB}"/>
+                <a16:creationId xmlns:a16="http://schemas.microsoft.com/office/drawing/2014/main" id="{9357C7B9-F968-49F0-80D2-C3D600C219C5}"/>
               </a:ext>
             </a:extLst>
           </p:cNvPr>
@@ -7481,7 +7504,7 @@
           <p:cNvPr id="2" name="">
             <a:extLst xmlns:a="http://schemas.openxmlformats.org/drawingml/2006/main">
               <a:ext uri="{FF2B5EF4-FFF2-40B4-BE49-F238E27FC236}">
-                <a16:creationId xmlns:a16="http://schemas.microsoft.com/office/drawing/2014/main" id="{030C2D3D-8C76-40DE-B3A5-BB5FF9A83F13}"/>
+                <a16:creationId xmlns:a16="http://schemas.microsoft.com/office/drawing/2014/main" id="{0F19CAC7-870E-4DE5-9F96-ABF42F154001}"/>
               </a:ext>
             </a:extLst>
           </p:cNvPr>
@@ -7549,7 +7572,7 @@
           <p:cNvPr id="3" name="">
             <a:extLst xmlns:a="http://schemas.openxmlformats.org/drawingml/2006/main">
               <a:ext uri="{FF2B5EF4-FFF2-40B4-BE49-F238E27FC236}">
-                <a16:creationId xmlns:a16="http://schemas.microsoft.com/office/drawing/2014/main" id="{175B0075-6ABC-49E6-AF23-24105A562804}"/>
+                <a16:creationId xmlns:a16="http://schemas.microsoft.com/office/drawing/2014/main" id="{EA82AB14-1ECC-44CD-9621-C6C2F277791D}"/>
               </a:ext>
             </a:extLst>
           </p:cNvPr>
@@ -7777,7 +7800,7 @@
           <p:cNvPr id="4" name="">
             <a:extLst xmlns:a="http://schemas.openxmlformats.org/drawingml/2006/main">
               <a:ext uri="{FF2B5EF4-FFF2-40B4-BE49-F238E27FC236}">
-                <a16:creationId xmlns:a16="http://schemas.microsoft.com/office/drawing/2014/main" id="{719C9A49-B0E9-4122-96E7-21F80D2E4C2B}"/>
+                <a16:creationId xmlns:a16="http://schemas.microsoft.com/office/drawing/2014/main" id="{2E0580E7-C396-4F3E-B252-A3016453D98B}"/>
               </a:ext>
             </a:extLst>
           </p:cNvPr>
@@ -7866,7 +7889,7 @@
     </p:spTree>
     <p:extLst>
       <p:ext uri="{BB962C8B-B14F-4D97-AF65-F5344CB8AC3E}">
-        <p14:creationId xmlns:p14="http://schemas.microsoft.com/office/powerpoint/2010/main" val="1918642322"/>
+        <p14:creationId xmlns:p14="http://schemas.microsoft.com/office/powerpoint/2010/main" val="1543300159"/>
       </p:ext>
     </p:extLst>
   </p:cSld>
@@ -7897,7 +7920,7 @@
           <p:cNvPr id="10" name="">
             <a:extLst xmlns:a="http://schemas.openxmlformats.org/drawingml/2006/main">
               <a:ext uri="{FF2B5EF4-FFF2-40B4-BE49-F238E27FC236}">
-                <a16:creationId xmlns:a16="http://schemas.microsoft.com/office/drawing/2014/main" id="{AF38DC07-D844-4E9E-8C80-09B1C295E5CE}"/>
+                <a16:creationId xmlns:a16="http://schemas.microsoft.com/office/drawing/2014/main" id="{554359DC-8F0E-4729-BC96-CC0E4E2D6C01}"/>
               </a:ext>
             </a:extLst>
           </p:cNvPr>
@@ -7965,7 +7988,7 @@
           <p:cNvPr id="2" name="">
             <a:extLst xmlns:a="http://schemas.openxmlformats.org/drawingml/2006/main">
               <a:ext uri="{FF2B5EF4-FFF2-40B4-BE49-F238E27FC236}">
-                <a16:creationId xmlns:a16="http://schemas.microsoft.com/office/drawing/2014/main" id="{611E61A1-7C6B-4D10-A54D-39AF41DCCE54}"/>
+                <a16:creationId xmlns:a16="http://schemas.microsoft.com/office/drawing/2014/main" id="{CD598E10-1E9D-4864-A761-741C9CCC37FD}"/>
               </a:ext>
             </a:extLst>
           </p:cNvPr>
@@ -8033,7 +8056,7 @@
           <p:cNvPr id="3" name="">
             <a:extLst xmlns:a="http://schemas.openxmlformats.org/drawingml/2006/main">
               <a:ext uri="{FF2B5EF4-FFF2-40B4-BE49-F238E27FC236}">
-                <a16:creationId xmlns:a16="http://schemas.microsoft.com/office/drawing/2014/main" id="{C3B01C60-D5AD-4EDD-9323-E95402878AF3}"/>
+                <a16:creationId xmlns:a16="http://schemas.microsoft.com/office/drawing/2014/main" id="{895FF3AA-024E-4F01-B182-3275C821DA35}"/>
               </a:ext>
             </a:extLst>
           </p:cNvPr>
@@ -8101,7 +8124,7 @@
           <p:cNvPr id="4" name="">
             <a:extLst xmlns:a="http://schemas.openxmlformats.org/drawingml/2006/main">
               <a:ext uri="{FF2B5EF4-FFF2-40B4-BE49-F238E27FC236}">
-                <a16:creationId xmlns:a16="http://schemas.microsoft.com/office/drawing/2014/main" id="{B04F5358-002E-4B9B-B136-C68EE25779B5}"/>
+                <a16:creationId xmlns:a16="http://schemas.microsoft.com/office/drawing/2014/main" id="{251C7127-129E-405C-B0BD-16BF6947D4B3}"/>
               </a:ext>
             </a:extLst>
           </p:cNvPr>
@@ -8169,7 +8192,7 @@
           <p:cNvPr id="5" name="">
             <a:extLst xmlns:a="http://schemas.openxmlformats.org/drawingml/2006/main">
               <a:ext uri="{FF2B5EF4-FFF2-40B4-BE49-F238E27FC236}">
-                <a16:creationId xmlns:a16="http://schemas.microsoft.com/office/drawing/2014/main" id="{8759401C-33AB-4924-B53E-2270E07A77BD}"/>
+                <a16:creationId xmlns:a16="http://schemas.microsoft.com/office/drawing/2014/main" id="{C70C045B-C408-4721-83EE-6470F6F4548C}"/>
               </a:ext>
             </a:extLst>
           </p:cNvPr>
@@ -8237,7 +8260,7 @@
           <p:cNvPr id="6" name="">
             <a:extLst xmlns:a="http://schemas.openxmlformats.org/drawingml/2006/main">
               <a:ext uri="{FF2B5EF4-FFF2-40B4-BE49-F238E27FC236}">
-                <a16:creationId xmlns:a16="http://schemas.microsoft.com/office/drawing/2014/main" id="{9B024682-32BA-47A5-80FF-F9C461B6266A}"/>
+                <a16:creationId xmlns:a16="http://schemas.microsoft.com/office/drawing/2014/main" id="{DE5CEC79-32E9-455C-818F-76E41B3C3075}"/>
               </a:ext>
             </a:extLst>
           </p:cNvPr>
@@ -8351,7 +8374,7 @@
           <p:cNvPr id="7" name="">
             <a:extLst xmlns:a="http://schemas.openxmlformats.org/drawingml/2006/main">
               <a:ext uri="{FF2B5EF4-FFF2-40B4-BE49-F238E27FC236}">
-                <a16:creationId xmlns:a16="http://schemas.microsoft.com/office/drawing/2014/main" id="{2DFF6E38-2A3D-4093-8259-07AE1B48360E}"/>
+                <a16:creationId xmlns:a16="http://schemas.microsoft.com/office/drawing/2014/main" id="{8AD11145-DE5E-46A1-BC50-C34FF167E0A6}"/>
               </a:ext>
             </a:extLst>
           </p:cNvPr>
@@ -8419,7 +8442,7 @@
           <p:cNvPr id="8" name="">
             <a:extLst xmlns:a="http://schemas.openxmlformats.org/drawingml/2006/main">
               <a:ext uri="{FF2B5EF4-FFF2-40B4-BE49-F238E27FC236}">
-                <a16:creationId xmlns:a16="http://schemas.microsoft.com/office/drawing/2014/main" id="{2F19E343-813B-4CE5-BA95-0AA8DE475FCF}"/>
+                <a16:creationId xmlns:a16="http://schemas.microsoft.com/office/drawing/2014/main" id="{7D69BE49-8002-43CD-AED3-0C71DCE47A11}"/>
               </a:ext>
             </a:extLst>
           </p:cNvPr>
@@ -8510,7 +8533,7 @@
           <p:cNvPr id="9" name="">
             <a:extLst xmlns:a="http://schemas.openxmlformats.org/drawingml/2006/main">
               <a:ext uri="{FF2B5EF4-FFF2-40B4-BE49-F238E27FC236}">
-                <a16:creationId xmlns:a16="http://schemas.microsoft.com/office/drawing/2014/main" id="{93B8D79D-0953-43C2-830E-3F61E998C1D9}"/>
+                <a16:creationId xmlns:a16="http://schemas.microsoft.com/office/drawing/2014/main" id="{6B78FA72-80F3-4328-8712-856AF110FB42}"/>
               </a:ext>
             </a:extLst>
           </p:cNvPr>
@@ -8576,7 +8599,7 @@
     </p:spTree>
     <p:extLst>
       <p:ext uri="{BB962C8B-B14F-4D97-AF65-F5344CB8AC3E}">
-        <p14:creationId xmlns:p14="http://schemas.microsoft.com/office/powerpoint/2010/main" val="1311443817"/>
+        <p14:creationId xmlns:p14="http://schemas.microsoft.com/office/powerpoint/2010/main" val="1898025865"/>
       </p:ext>
     </p:extLst>
   </p:cSld>
@@ -8607,7 +8630,7 @@
           <p:cNvPr id="11" name="">
             <a:extLst xmlns:a="http://schemas.openxmlformats.org/drawingml/2006/main">
               <a:ext uri="{FF2B5EF4-FFF2-40B4-BE49-F238E27FC236}">
-                <a16:creationId xmlns:a16="http://schemas.microsoft.com/office/drawing/2014/main" id="{F47D5D6E-2670-4FFE-B32E-1DB177173D1C}"/>
+                <a16:creationId xmlns:a16="http://schemas.microsoft.com/office/drawing/2014/main" id="{2C10338F-E12E-47D3-84AC-AF759B989532}"/>
               </a:ext>
             </a:extLst>
           </p:cNvPr>
@@ -8675,7 +8698,7 @@
           <p:cNvPr id="2" name="">
             <a:extLst xmlns:a="http://schemas.openxmlformats.org/drawingml/2006/main">
               <a:ext uri="{FF2B5EF4-FFF2-40B4-BE49-F238E27FC236}">
-                <a16:creationId xmlns:a16="http://schemas.microsoft.com/office/drawing/2014/main" id="{6B78B820-DE9B-4C3D-8EEB-B8232304966D}"/>
+                <a16:creationId xmlns:a16="http://schemas.microsoft.com/office/drawing/2014/main" id="{57824F83-9257-4333-BDAF-A4C7397EBF03}"/>
               </a:ext>
             </a:extLst>
           </p:cNvPr>
@@ -8743,7 +8766,7 @@
           <p:cNvPr id="3" name="">
             <a:extLst xmlns:a="http://schemas.openxmlformats.org/drawingml/2006/main">
               <a:ext uri="{FF2B5EF4-FFF2-40B4-BE49-F238E27FC236}">
-                <a16:creationId xmlns:a16="http://schemas.microsoft.com/office/drawing/2014/main" id="{A321545B-70F7-4E27-AD8C-7DF69F64BF5B}"/>
+                <a16:creationId xmlns:a16="http://schemas.microsoft.com/office/drawing/2014/main" id="{70502FDC-6A58-480A-83E4-5E82A0EC592C}"/>
               </a:ext>
             </a:extLst>
           </p:cNvPr>
@@ -8811,7 +8834,7 @@
           <p:cNvPr id="4" name="">
             <a:extLst xmlns:a="http://schemas.openxmlformats.org/drawingml/2006/main">
               <a:ext uri="{FF2B5EF4-FFF2-40B4-BE49-F238E27FC236}">
-                <a16:creationId xmlns:a16="http://schemas.microsoft.com/office/drawing/2014/main" id="{9158A314-1606-4F81-873D-6460089AAB8B}"/>
+                <a16:creationId xmlns:a16="http://schemas.microsoft.com/office/drawing/2014/main" id="{7CFD0BA2-5CFB-4C5B-A2B0-E5E7FA44649B}"/>
               </a:ext>
             </a:extLst>
           </p:cNvPr>
@@ -8925,7 +8948,7 @@
           <p:cNvPr id="5" name="">
             <a:extLst xmlns:a="http://schemas.openxmlformats.org/drawingml/2006/main">
               <a:ext uri="{FF2B5EF4-FFF2-40B4-BE49-F238E27FC236}">
-                <a16:creationId xmlns:a16="http://schemas.microsoft.com/office/drawing/2014/main" id="{87F764D9-E801-4072-A686-709B2047DA3D}"/>
+                <a16:creationId xmlns:a16="http://schemas.microsoft.com/office/drawing/2014/main" id="{B0267F16-0148-4D8B-A995-0F019657627B}"/>
               </a:ext>
             </a:extLst>
           </p:cNvPr>
@@ -8993,7 +9016,7 @@
           <p:cNvPr id="6" name="">
             <a:extLst xmlns:a="http://schemas.openxmlformats.org/drawingml/2006/main">
               <a:ext uri="{FF2B5EF4-FFF2-40B4-BE49-F238E27FC236}">
-                <a16:creationId xmlns:a16="http://schemas.microsoft.com/office/drawing/2014/main" id="{DE0128FC-0F1C-48B0-980F-834CC0E6B36D}"/>
+                <a16:creationId xmlns:a16="http://schemas.microsoft.com/office/drawing/2014/main" id="{482A252D-299F-4CC2-BB8E-DFBDBDA9C965}"/>
               </a:ext>
             </a:extLst>
           </p:cNvPr>
@@ -9107,7 +9130,7 @@
           <p:cNvPr id="7" name="">
             <a:extLst xmlns:a="http://schemas.openxmlformats.org/drawingml/2006/main">
               <a:ext uri="{FF2B5EF4-FFF2-40B4-BE49-F238E27FC236}">
-                <a16:creationId xmlns:a16="http://schemas.microsoft.com/office/drawing/2014/main" id="{BDE8A449-0D71-482E-893B-20A008CC5E11}"/>
+                <a16:creationId xmlns:a16="http://schemas.microsoft.com/office/drawing/2014/main" id="{7871EEDD-BFBC-47F9-99A5-6D908226CE8B}"/>
               </a:ext>
             </a:extLst>
           </p:cNvPr>
@@ -9175,7 +9198,7 @@
           <p:cNvPr id="8" name="">
             <a:extLst xmlns:a="http://schemas.openxmlformats.org/drawingml/2006/main">
               <a:ext uri="{FF2B5EF4-FFF2-40B4-BE49-F238E27FC236}">
-                <a16:creationId xmlns:a16="http://schemas.microsoft.com/office/drawing/2014/main" id="{9CE9613B-944B-4DB3-8427-69E7046645AB}"/>
+                <a16:creationId xmlns:a16="http://schemas.microsoft.com/office/drawing/2014/main" id="{A12978E4-9127-4E59-9EA3-90DF0D883F44}"/>
               </a:ext>
             </a:extLst>
           </p:cNvPr>
@@ -9289,7 +9312,7 @@
           <p:cNvPr id="9" name="">
             <a:extLst xmlns:a="http://schemas.openxmlformats.org/drawingml/2006/main">
               <a:ext uri="{FF2B5EF4-FFF2-40B4-BE49-F238E27FC236}">
-                <a16:creationId xmlns:a16="http://schemas.microsoft.com/office/drawing/2014/main" id="{FE9AA0FE-F537-4DFA-BEB9-3A4B3334131F}"/>
+                <a16:creationId xmlns:a16="http://schemas.microsoft.com/office/drawing/2014/main" id="{1281139E-BF68-4B99-9768-EFA7B6957127}"/>
               </a:ext>
             </a:extLst>
           </p:cNvPr>
@@ -9357,7 +9380,7 @@
           <p:cNvPr id="10" name="">
             <a:extLst xmlns:a="http://schemas.openxmlformats.org/drawingml/2006/main">
               <a:ext uri="{FF2B5EF4-FFF2-40B4-BE49-F238E27FC236}">
-                <a16:creationId xmlns:a16="http://schemas.microsoft.com/office/drawing/2014/main" id="{5684B9CE-D09F-4B3D-A2D4-3076D5143D2F}"/>
+                <a16:creationId xmlns:a16="http://schemas.microsoft.com/office/drawing/2014/main" id="{F4E0534E-A2EC-40BC-A7ED-EB742205B1BF}"/>
               </a:ext>
             </a:extLst>
           </p:cNvPr>
@@ -9446,7 +9469,7 @@
     </p:spTree>
     <p:extLst>
       <p:ext uri="{BB962C8B-B14F-4D97-AF65-F5344CB8AC3E}">
-        <p14:creationId xmlns:p14="http://schemas.microsoft.com/office/powerpoint/2010/main" val="368064338"/>
+        <p14:creationId xmlns:p14="http://schemas.microsoft.com/office/powerpoint/2010/main" val="1859416455"/>
       </p:ext>
     </p:extLst>
   </p:cSld>

</xml_diff>